<commit_message>
Address bar raiser findings on cost limitation and diagram
</commit_message>
<xml_diff>
--- a/diagrams/Dormant Account Detection Dashboard.pptx
+++ b/diagrams/Dormant Account Detection Dashboard.pptx
@@ -3105,8 +3105,8 @@
         </p:blipFill>
         <p:spPr>
           <a:xfrm>
-            <a:off x="1145806" y="680000"/>
-            <a:ext cx="9900388" cy="5878000"/>
+            <a:off x="1978214" y="680000"/>
+            <a:ext cx="8235571" cy="5878000"/>
           </a:xfrm>
           <a:prstGeom prst="rect">
             <a:avLst/>
@@ -3181,8 +3181,8 @@
         </p:blipFill>
         <p:spPr>
           <a:xfrm>
-            <a:off x="1145806" y="680000"/>
-            <a:ext cx="9900388" cy="5878000"/>
+            <a:off x="1978214" y="680000"/>
+            <a:ext cx="8235571" cy="5878000"/>
           </a:xfrm>
           <a:prstGeom prst="rect">
             <a:avLst/>

</xml_diff>

<commit_message>
Address bar raiser findings on cost limitation and diagram (#2)
Reword the Cost Explorer limitation as a design choice. Add the CloudWatch metrics store, the trend-history path (9b), and the widget Lambda function (10) to the diagram, and regenerate the JPG and PowerPoint.
</commit_message>
<xml_diff>
--- a/diagrams/Dormant Account Detection Dashboard.pptx
+++ b/diagrams/Dormant Account Detection Dashboard.pptx
@@ -3105,8 +3105,8 @@
         </p:blipFill>
         <p:spPr>
           <a:xfrm>
-            <a:off x="1145806" y="680000"/>
-            <a:ext cx="9900388" cy="5878000"/>
+            <a:off x="1978214" y="680000"/>
+            <a:ext cx="8235571" cy="5878000"/>
           </a:xfrm>
           <a:prstGeom prst="rect">
             <a:avLst/>
@@ -3181,8 +3181,8 @@
         </p:blipFill>
         <p:spPr>
           <a:xfrm>
-            <a:off x="1145806" y="680000"/>
-            <a:ext cx="9900388" cy="5878000"/>
+            <a:off x="1978214" y="680000"/>
+            <a:ext cx="8235571" cy="5878000"/>
           </a:xfrm>
           <a:prstGeom prst="rect">
             <a:avLst/>

</xml_diff>